<commit_message>
pitch: clearer data-center and firefighter captions and script
</commit_message>
<xml_diff>
--- a/docs/pitch/Firefly-Pitch.pptx
+++ b/docs/pitch/Firefly-Pitch.pptx
@@ -863,7 +863,7 @@
           <a:lstStyle/>
           <a:p>
             <a:r>
-              <a:t>The Navy lost four billion dollars to fifteen warship fires, and two of the ships with it. Commercial buildings: eight percent of US fires, twenty percent of the damage. A data center loses fourteen thousand dollars a minute. ‖ And firefighters — a small crew needs twenty-three extra minutes to work a high-rise. They're not fighting yet. They're still looking.</a:t>
+              <a:t>The Navy lost four billion dollars to fifteen warship fires, and two of the ships with it. Commercial buildings: eight percent of US fires, twenty percent of the damage. A data center loses fourteen thousand dollars a minute offline, and fire is the biggest single cause of its insurance losses. ‖ And firefighters. NIST timed real crews in a thirteen-story building. A small crew needed twenty-three extra minutes before water was on the fire, and most of that is climbing, hauling, and finding it. That is the window Firefly is built to close.</a:t>
             </a:r>
           </a:p>
         </p:txBody>
@@ -7077,7 +7077,7 @@
                 </a:solidFill>
                 <a:latin typeface="Arial"/>
               </a:rPr>
-              <a:t>Downtime. Fire drives over half of claim severity.</a:t>
+              <a:t>Every minute offline. Fire is the biggest single cause of data-center insurance losses.</a:t>
             </a:r>
           </a:p>
         </p:txBody>
@@ -7230,7 +7230,7 @@
                 </a:solidFill>
                 <a:latin typeface="Arial"/>
               </a:rPr>
-              <a:t>Extra time a small crew needs in a high-rise. 62 died on duty in 2024.</a:t>
+              <a:t>Extra minutes a small crew spends climbing, hauling, and finding the fire before water is on it. The gap Firefly closes. 62 died on duty in 2024.</a:t>
             </a:r>
           </a:p>
         </p:txBody>

</xml_diff>